<commit_message>
Update ANOVA chapter and textbook navigation
</commit_message>
<xml_diff>
--- a/HHS627 Quarto Slides/Week 2.pptx
+++ b/HHS627 Quarto Slides/Week 2.pptx
@@ -6083,4 +6083,10 @@
     </a:ext>
   </a:extLst>
 </a:theme>
+</file>
+
+<file path=docMetadata/LabelInfo.xml><?xml version="1.0" encoding="utf-8"?>
+<clbl:labelList xmlns:clbl="http://schemas.microsoft.com/office/2020/mipLabelMetadata">
+  <clbl:label id="{a2761ec8-7198-4440-bea0-e9dd2af28b51}" enabled="1" method="Standard" siteId="{73e15cf5-5dbb-46af-a862-753916269d73}" removed="0"/>
+</clbl:labelList>
 </file>
</xml_diff>